<commit_message>
Update presentation slides (PPTX and PDF) and camera config
</commit_message>
<xml_diff>
--- a/slides/So_Sereysokbotra_Cambodia_ALPR.pptx
+++ b/slides/So_Sereysokbotra_Cambodia_ALPR.pptx
@@ -500,39 +500,100 @@
           <a:lstStyle/>
           <a:p>
             <a:r>
+              <a:rPr dirty="0"/>
               <a:t>Model C makes 34 errors out of 567.</a:t>
             </a:r>
           </a:p>
           <a:p>
-            <a:endParaRPr/>
-          </a:p>
-          <a:p>
-            <a:r>
-              <a:t>Eight of them — a quarter — are a single pair: Banteay Meanchey and Oudor Meanchey. On a plate both names are abbreviated — point at the card *bor*-dot-meanchey and *oo*-dot-meanchey. The entire decision rests on one small leading letter, and on a blurred plate that letter is gone.</a:t>
-            </a:r>
-          </a:p>
-          <a:p>
-            <a:endParaRPr/>
-          </a:p>
-          <a:p>
-            <a:r>
-              <a:t>The other frequent confusions are the same story — Battambang and Pursat, Kampong Chhnang and Kampong Thom — names that share a whole word.</a:t>
-            </a:r>
-          </a:p>
-          <a:p>
-            <a:endParaRPr/>
-          </a:p>
-          <a:p>
-            <a:r>
+            <a:endParaRPr dirty="0"/>
+          </a:p>
+          <a:p>
+            <a:r>
+              <a:rPr dirty="0"/>
+              <a:t>Eight of them — a quarter — are a single pair: Banteay Meanchey and </a:t>
+            </a:r>
+            <a:r>
+              <a:rPr dirty="0" err="1"/>
+              <a:t>Oudor</a:t>
+            </a:r>
+            <a:r>
+              <a:rPr dirty="0"/>
+              <a:t> Meanchey. On a plate both names are abbreviated — point at the card *</a:t>
+            </a:r>
+            <a:r>
+              <a:rPr dirty="0" err="1"/>
+              <a:t>bor</a:t>
+            </a:r>
+            <a:r>
+              <a:rPr dirty="0"/>
+              <a:t>*-dot-</a:t>
+            </a:r>
+            <a:r>
+              <a:rPr dirty="0" err="1"/>
+              <a:t>meanchey</a:t>
+            </a:r>
+            <a:r>
+              <a:rPr dirty="0"/>
+              <a:t> and *</a:t>
+            </a:r>
+            <a:r>
+              <a:rPr dirty="0" err="1"/>
+              <a:t>oo</a:t>
+            </a:r>
+            <a:r>
+              <a:rPr dirty="0"/>
+              <a:t>*-dot-</a:t>
+            </a:r>
+            <a:r>
+              <a:rPr dirty="0" err="1"/>
+              <a:t>meanchey</a:t>
+            </a:r>
+            <a:r>
+              <a:rPr dirty="0"/>
+              <a:t>. The entire decision rests on one small leading letter, and on a blurred plate that letter is gone.</a:t>
+            </a:r>
+          </a:p>
+          <a:p>
+            <a:endParaRPr dirty="0"/>
+          </a:p>
+          <a:p>
+            <a:r>
+              <a:rPr dirty="0"/>
+              <a:t>The other frequent confusions are the same story — Battambang and </a:t>
+            </a:r>
+            <a:r>
+              <a:rPr dirty="0" err="1"/>
+              <a:t>Pursat</a:t>
+            </a:r>
+            <a:r>
+              <a:rPr dirty="0"/>
+              <a:t>, Kampong Chhnang and Kampong Thom — names that share a whole word.</a:t>
+            </a:r>
+          </a:p>
+          <a:p>
+            <a:endParaRPr dirty="0"/>
+          </a:p>
+          <a:p>
+            <a:r>
+              <a:rPr dirty="0"/>
               <a:t>point at the gallery Most remaining errors are crops a human cannot read either — motion blur, twenty-pixel text, JPEG blocks.</a:t>
             </a:r>
           </a:p>
           <a:p>
-            <a:endParaRPr/>
-          </a:p>
-          <a:p>
-            <a:r>
-              <a:t>And class size matters less than I expected: the four smallest classes score 90 percent against 94.2 for the rest, and Mondul Kiri gets five out of five on 18 training crops. It is the visual similarity of the name, not the amount of data, that drives the errors.</a:t>
+            <a:endParaRPr dirty="0"/>
+          </a:p>
+          <a:p>
+            <a:r>
+              <a:rPr dirty="0"/>
+              <a:t>And class size matters less than I expected: the four smallest classes score 90 percent against 94.2 for the rest, and </a:t>
+            </a:r>
+            <a:r>
+              <a:rPr dirty="0" err="1"/>
+              <a:t>Mondul</a:t>
+            </a:r>
+            <a:r>
+              <a:rPr dirty="0"/>
+              <a:t> Kiri gets five out of five on 18 training crops. It is the visual similarity of the name, not the amount of data, that drives the errors.</a:t>
             </a:r>
           </a:p>
         </p:txBody>
@@ -969,30 +1030,42 @@
           <a:lstStyle/>
           <a:p>
             <a:r>
-              <a:t>point at the cards Across Cambodia, automated barriers, residential boreys, smart parking, and highway toll plazas need fast, hands-free vehicle entry.</a:t>
-            </a:r>
-          </a:p>
-          <a:p>
-            <a:endParaRPr/>
-          </a:p>
-          <a:p>
-            <a:r>
+              <a:rPr dirty="0"/>
+              <a:t>point at the cards Across Cambodia, automated barriers, residential </a:t>
+            </a:r>
+            <a:r>
+              <a:rPr dirty="0" err="1"/>
+              <a:t>boreys</a:t>
+            </a:r>
+            <a:r>
+              <a:rPr dirty="0"/>
+              <a:t>, smart parking, and highway toll plazas need fast, hands-free vehicle entry.</a:t>
+            </a:r>
+          </a:p>
+          <a:p>
+            <a:endParaRPr dirty="0"/>
+          </a:p>
+          <a:p>
+            <a:r>
+              <a:rPr dirty="0"/>
               <a:t>Commercial ALPR systems fail here because of one critical fact: the plate number alone is not unique in Cambodia. The number `2A-0243` repeats in almost every one of the 26 provinces. If a security gate reads only the digits, an unauthorized car from another province could falsely trigger access.</a:t>
             </a:r>
           </a:p>
           <a:p>
-            <a:endParaRPr/>
-          </a:p>
-          <a:p>
-            <a:r>
+            <a:endParaRPr dirty="0"/>
+          </a:p>
+          <a:p>
+            <a:r>
+              <a:rPr dirty="0"/>
               <a:t>Furthermore, off-the-shelf Western OCR engines cannot read the top line because Khmer script has complex stacked ligatures that break character-by-character segmentation.</a:t>
             </a:r>
           </a:p>
           <a:p>
-            <a:endParaRPr/>
-          </a:p>
-          <a:p>
-            <a:r>
+            <a:endParaRPr dirty="0"/>
+          </a:p>
+          <a:p>
+            <a:r>
+              <a:rPr dirty="0"/>
               <a:t>point at the diagram So I treat the Khmer province line as a whole-image classification problem: a 128-by-128 crop in, one of 26 classes out. This research asks: on a small, imbalanced Khmer dataset, which deep-learning approach reads this line best, and why?</a:t>
             </a:r>
           </a:p>
@@ -1886,7 +1959,7 @@
           <a:p>
             <a:fld id="{5BCAD085-E8A6-8845-BD4E-CB4CCA059FC4}" type="datetimeFigureOut">
               <a:rPr lang="en-US" smtClean="0"/>
-              <a:t>10/17/2026</a:t>
+              <a:t>10/23/2026</a:t>
             </a:fld>
             <a:endParaRPr lang="en-US"/>
           </a:p>
@@ -2054,7 +2127,7 @@
           <a:p>
             <a:fld id="{5BCAD085-E8A6-8845-BD4E-CB4CCA059FC4}" type="datetimeFigureOut">
               <a:rPr lang="en-US" smtClean="0"/>
-              <a:t>10/17/2026</a:t>
+              <a:t>10/23/2026</a:t>
             </a:fld>
             <a:endParaRPr lang="en-US"/>
           </a:p>
@@ -2232,7 +2305,7 @@
           <a:p>
             <a:fld id="{5BCAD085-E8A6-8845-BD4E-CB4CCA059FC4}" type="datetimeFigureOut">
               <a:rPr lang="en-US" smtClean="0"/>
-              <a:t>10/17/2026</a:t>
+              <a:t>10/23/2026</a:t>
             </a:fld>
             <a:endParaRPr lang="en-US"/>
           </a:p>
@@ -2400,7 +2473,7 @@
           <a:p>
             <a:fld id="{5BCAD085-E8A6-8845-BD4E-CB4CCA059FC4}" type="datetimeFigureOut">
               <a:rPr lang="en-US" smtClean="0"/>
-              <a:t>10/17/2026</a:t>
+              <a:t>10/23/2026</a:t>
             </a:fld>
             <a:endParaRPr lang="en-US"/>
           </a:p>
@@ -2645,7 +2718,7 @@
           <a:p>
             <a:fld id="{5BCAD085-E8A6-8845-BD4E-CB4CCA059FC4}" type="datetimeFigureOut">
               <a:rPr lang="en-US" smtClean="0"/>
-              <a:t>10/17/2026</a:t>
+              <a:t>10/23/2026</a:t>
             </a:fld>
             <a:endParaRPr lang="en-US"/>
           </a:p>
@@ -2930,7 +3003,7 @@
           <a:p>
             <a:fld id="{5BCAD085-E8A6-8845-BD4E-CB4CCA059FC4}" type="datetimeFigureOut">
               <a:rPr lang="en-US" smtClean="0"/>
-              <a:t>10/17/2026</a:t>
+              <a:t>10/23/2026</a:t>
             </a:fld>
             <a:endParaRPr lang="en-US"/>
           </a:p>
@@ -3349,7 +3422,7 @@
           <a:p>
             <a:fld id="{5BCAD085-E8A6-8845-BD4E-CB4CCA059FC4}" type="datetimeFigureOut">
               <a:rPr lang="en-US" smtClean="0"/>
-              <a:t>10/17/2026</a:t>
+              <a:t>10/23/2026</a:t>
             </a:fld>
             <a:endParaRPr lang="en-US"/>
           </a:p>
@@ -3466,7 +3539,7 @@
           <a:p>
             <a:fld id="{5BCAD085-E8A6-8845-BD4E-CB4CCA059FC4}" type="datetimeFigureOut">
               <a:rPr lang="en-US" smtClean="0"/>
-              <a:t>10/17/2026</a:t>
+              <a:t>10/23/2026</a:t>
             </a:fld>
             <a:endParaRPr lang="en-US"/>
           </a:p>
@@ -3561,7 +3634,7 @@
           <a:p>
             <a:fld id="{5BCAD085-E8A6-8845-BD4E-CB4CCA059FC4}" type="datetimeFigureOut">
               <a:rPr lang="en-US" smtClean="0"/>
-              <a:t>10/17/2026</a:t>
+              <a:t>10/23/2026</a:t>
             </a:fld>
             <a:endParaRPr lang="en-US"/>
           </a:p>
@@ -3836,7 +3909,7 @@
           <a:p>
             <a:fld id="{5BCAD085-E8A6-8845-BD4E-CB4CCA059FC4}" type="datetimeFigureOut">
               <a:rPr lang="en-US" smtClean="0"/>
-              <a:t>10/17/2026</a:t>
+              <a:t>10/23/2026</a:t>
             </a:fld>
             <a:endParaRPr lang="en-US"/>
           </a:p>
@@ -4088,7 +4161,7 @@
           <a:p>
             <a:fld id="{5BCAD085-E8A6-8845-BD4E-CB4CCA059FC4}" type="datetimeFigureOut">
               <a:rPr lang="en-US" smtClean="0"/>
-              <a:t>10/17/2026</a:t>
+              <a:t>10/23/2026</a:t>
             </a:fld>
             <a:endParaRPr lang="en-US"/>
           </a:p>
@@ -4299,7 +4372,7 @@
           <a:p>
             <a:fld id="{5BCAD085-E8A6-8845-BD4E-CB4CCA059FC4}" type="datetimeFigureOut">
               <a:rPr lang="en-US" smtClean="0"/>
-              <a:t>10/17/2026</a:t>
+              <a:t>10/23/2026</a:t>
             </a:fld>
             <a:endParaRPr lang="en-US"/>
           </a:p>
@@ -8143,7 +8216,7 @@
           <a:lstStyle/>
           <a:p>
             <a:r>
-              <a:rPr sz="3000" b="1" i="0">
+              <a:rPr sz="3000" b="1" i="0" dirty="0">
                 <a:solidFill>
                   <a:srgbClr val="C0392B"/>
                 </a:solidFill>
@@ -8154,13 +8227,31 @@
           </a:p>
           <a:p>
             <a:r>
-              <a:rPr sz="1100" b="0" i="0">
+              <a:rPr sz="1100" b="0" i="0" dirty="0">
                 <a:solidFill>
                   <a:srgbClr val="6B7280"/>
                 </a:solidFill>
                 <a:latin typeface="Segoe UI"/>
               </a:rPr>
-              <a:t>one pair — Banteay ↔ Oudor Meanchey</a:t>
+              <a:t>one pair — Banteay ↔ </a:t>
+            </a:r>
+            <a:r>
+              <a:rPr sz="1100" b="0" i="0" dirty="0" err="1">
+                <a:solidFill>
+                  <a:srgbClr val="6B7280"/>
+                </a:solidFill>
+                <a:latin typeface="Segoe UI"/>
+              </a:rPr>
+              <a:t>Oudor</a:t>
+            </a:r>
+            <a:r>
+              <a:rPr sz="1100" b="0" i="0" dirty="0">
+                <a:solidFill>
+                  <a:srgbClr val="6B7280"/>
+                </a:solidFill>
+                <a:latin typeface="Segoe UI"/>
+              </a:rPr>
+              <a:t> Meanchey</a:t>
             </a:r>
           </a:p>
         </p:txBody>
@@ -41414,8 +41505,8 @@
         </p:nvSpPr>
         <p:spPr>
           <a:xfrm>
-            <a:off x="640080" y="3931920"/>
-            <a:ext cx="2577007" cy="2176272"/>
+            <a:off x="640080" y="4276051"/>
+            <a:ext cx="2577007" cy="1220725"/>
           </a:xfrm>
           <a:prstGeom prst="roundRect">
             <a:avLst>
@@ -41456,57 +41547,13 @@
       </p:sp>
       <p:sp>
         <p:nvSpPr>
-          <p:cNvPr id="24" name="Rectangle 23"/>
-          <p:cNvSpPr/>
-          <p:nvPr/>
-        </p:nvSpPr>
-        <p:spPr>
-          <a:xfrm>
-            <a:off x="640080" y="3931920"/>
-            <a:ext cx="2577007" cy="45720"/>
-          </a:xfrm>
-          <a:prstGeom prst="rect">
-            <a:avLst/>
-          </a:prstGeom>
-          <a:solidFill>
-            <a:srgbClr val="0F7C74"/>
-          </a:solidFill>
-          <a:ln>
-            <a:noFill/>
-          </a:ln>
-          <a:effectLst/>
-        </p:spPr>
-        <p:style>
-          <a:lnRef idx="1">
-            <a:schemeClr val="accent1"/>
-          </a:lnRef>
-          <a:fillRef idx="3">
-            <a:schemeClr val="accent1"/>
-          </a:fillRef>
-          <a:effectRef idx="2">
-            <a:schemeClr val="accent1"/>
-          </a:effectRef>
-          <a:fontRef idx="minor">
-            <a:schemeClr val="lt1"/>
-          </a:fontRef>
-        </p:style>
-        <p:txBody>
-          <a:bodyPr rtlCol="0" anchor="ctr"/>
-          <a:lstStyle/>
-          <a:p>
-            <a:endParaRPr/>
-          </a:p>
-        </p:txBody>
-      </p:sp>
-      <p:sp>
-        <p:nvSpPr>
           <p:cNvPr id="25" name="TextBox 24"/>
           <p:cNvSpPr txBox="1"/>
           <p:nvPr/>
         </p:nvSpPr>
         <p:spPr>
           <a:xfrm>
-            <a:off x="822959" y="4078224"/>
+            <a:off x="822959" y="4422355"/>
             <a:ext cx="2211247" cy="219456"/>
           </a:xfrm>
           <a:prstGeom prst="rect">
@@ -41541,7 +41588,7 @@
         </p:nvSpPr>
         <p:spPr>
           <a:xfrm>
-            <a:off x="822959" y="4334256"/>
+            <a:off x="822959" y="4678387"/>
             <a:ext cx="2211247" cy="438912"/>
           </a:xfrm>
           <a:prstGeom prst="rect">
@@ -41602,7 +41649,7 @@
         </p:nvSpPr>
         <p:spPr>
           <a:xfrm>
-            <a:off x="822959" y="4828031"/>
+            <a:off x="822959" y="5172162"/>
             <a:ext cx="2211247" cy="13716"/>
           </a:xfrm>
           <a:prstGeom prst="rect">
@@ -41640,48 +41687,14 @@
       </p:sp>
       <p:sp>
         <p:nvSpPr>
-          <p:cNvPr id="28" name="TextBox 27"/>
-          <p:cNvSpPr txBox="1"/>
-          <p:nvPr/>
-        </p:nvSpPr>
-        <p:spPr>
-          <a:xfrm>
-            <a:off x="822959" y="4919472"/>
-            <a:ext cx="2211247" cy="1097280"/>
-          </a:xfrm>
-          <a:prstGeom prst="rect">
-            <a:avLst/>
-          </a:prstGeom>
-          <a:noFill/>
-        </p:spPr>
-        <p:txBody>
-          <a:bodyPr wrap="square">
-            <a:spAutoFit/>
-          </a:bodyPr>
-          <a:lstStyle/>
-          <a:p>
-            <a:r>
-              <a:rPr sz="1200" b="0" i="0">
-                <a:solidFill>
-                  <a:srgbClr val="6B7280"/>
-                </a:solidFill>
-                <a:latin typeface="Segoe UI"/>
-              </a:rPr>
-              <a:t>Does pre-training on natural images help learn low-resource Khmer strokes?</a:t>
-            </a:r>
-          </a:p>
-        </p:txBody>
-      </p:sp>
-      <p:sp>
-        <p:nvSpPr>
           <p:cNvPr id="29" name="Rounded Rectangle 28"/>
           <p:cNvSpPr/>
           <p:nvPr/>
         </p:nvSpPr>
         <p:spPr>
           <a:xfrm>
-            <a:off x="3418255" y="3931920"/>
-            <a:ext cx="2577007" cy="2176272"/>
+            <a:off x="3418255" y="4276051"/>
+            <a:ext cx="2577007" cy="1220725"/>
           </a:xfrm>
           <a:prstGeom prst="roundRect">
             <a:avLst>
@@ -41722,57 +41735,13 @@
       </p:sp>
       <p:sp>
         <p:nvSpPr>
-          <p:cNvPr id="30" name="Rectangle 29"/>
-          <p:cNvSpPr/>
-          <p:nvPr/>
-        </p:nvSpPr>
-        <p:spPr>
-          <a:xfrm>
-            <a:off x="3418255" y="3931920"/>
-            <a:ext cx="2577007" cy="45720"/>
-          </a:xfrm>
-          <a:prstGeom prst="rect">
-            <a:avLst/>
-          </a:prstGeom>
-          <a:solidFill>
-            <a:srgbClr val="E09A1A"/>
-          </a:solidFill>
-          <a:ln>
-            <a:noFill/>
-          </a:ln>
-          <a:effectLst/>
-        </p:spPr>
-        <p:style>
-          <a:lnRef idx="1">
-            <a:schemeClr val="accent1"/>
-          </a:lnRef>
-          <a:fillRef idx="3">
-            <a:schemeClr val="accent1"/>
-          </a:fillRef>
-          <a:effectRef idx="2">
-            <a:schemeClr val="accent1"/>
-          </a:effectRef>
-          <a:fontRef idx="minor">
-            <a:schemeClr val="lt1"/>
-          </a:fontRef>
-        </p:style>
-        <p:txBody>
-          <a:bodyPr rtlCol="0" anchor="ctr"/>
-          <a:lstStyle/>
-          <a:p>
-            <a:endParaRPr/>
-          </a:p>
-        </p:txBody>
-      </p:sp>
-      <p:sp>
-        <p:nvSpPr>
           <p:cNvPr id="31" name="TextBox 30"/>
           <p:cNvSpPr txBox="1"/>
           <p:nvPr/>
         </p:nvSpPr>
         <p:spPr>
           <a:xfrm>
-            <a:off x="3601135" y="4078224"/>
+            <a:off x="3601135" y="4422355"/>
             <a:ext cx="2211247" cy="219456"/>
           </a:xfrm>
           <a:prstGeom prst="rect">
@@ -41807,7 +41776,7 @@
         </p:nvSpPr>
         <p:spPr>
           <a:xfrm>
-            <a:off x="3601135" y="4334256"/>
+            <a:off x="3601135" y="4678387"/>
             <a:ext cx="2211247" cy="438912"/>
           </a:xfrm>
           <a:prstGeom prst="rect">
@@ -41868,7 +41837,7 @@
         </p:nvSpPr>
         <p:spPr>
           <a:xfrm>
-            <a:off x="3601135" y="4828031"/>
+            <a:off x="3601135" y="5172162"/>
             <a:ext cx="2211247" cy="13716"/>
           </a:xfrm>
           <a:prstGeom prst="rect">
@@ -41906,48 +41875,14 @@
       </p:sp>
       <p:sp>
         <p:nvSpPr>
-          <p:cNvPr id="34" name="TextBox 33"/>
-          <p:cNvSpPr txBox="1"/>
-          <p:nvPr/>
-        </p:nvSpPr>
-        <p:spPr>
-          <a:xfrm>
-            <a:off x="3601135" y="4919472"/>
-            <a:ext cx="2211247" cy="1097280"/>
-          </a:xfrm>
-          <a:prstGeom prst="rect">
-            <a:avLst/>
-          </a:prstGeom>
-          <a:noFill/>
-        </p:spPr>
-        <p:txBody>
-          <a:bodyPr wrap="square">
-            <a:spAutoFit/>
-          </a:bodyPr>
-          <a:lstStyle/>
-          <a:p>
-            <a:r>
-              <a:rPr sz="1200" b="0" i="0">
-                <a:solidFill>
-                  <a:srgbClr val="6B7280"/>
-                </a:solidFill>
-                <a:latin typeface="Segoe UI"/>
-              </a:rPr>
-              <a:t>Can off-the-shelf ImageNet representations read script without adaptation?</a:t>
-            </a:r>
-          </a:p>
-        </p:txBody>
-      </p:sp>
-      <p:sp>
-        <p:nvSpPr>
           <p:cNvPr id="35" name="Rounded Rectangle 34"/>
           <p:cNvSpPr/>
           <p:nvPr/>
         </p:nvSpPr>
         <p:spPr>
           <a:xfrm>
-            <a:off x="6196431" y="3931920"/>
-            <a:ext cx="2577007" cy="2176272"/>
+            <a:off x="6196431" y="4276051"/>
+            <a:ext cx="2577007" cy="1220725"/>
           </a:xfrm>
           <a:prstGeom prst="roundRect">
             <a:avLst>
@@ -41988,57 +41923,13 @@
       </p:sp>
       <p:sp>
         <p:nvSpPr>
-          <p:cNvPr id="36" name="Rectangle 35"/>
-          <p:cNvSpPr/>
-          <p:nvPr/>
-        </p:nvSpPr>
-        <p:spPr>
-          <a:xfrm>
-            <a:off x="6196431" y="3931920"/>
-            <a:ext cx="2577007" cy="45720"/>
-          </a:xfrm>
-          <a:prstGeom prst="rect">
-            <a:avLst/>
-          </a:prstGeom>
-          <a:solidFill>
-            <a:srgbClr val="C0392B"/>
-          </a:solidFill>
-          <a:ln>
-            <a:noFill/>
-          </a:ln>
-          <a:effectLst/>
-        </p:spPr>
-        <p:style>
-          <a:lnRef idx="1">
-            <a:schemeClr val="accent1"/>
-          </a:lnRef>
-          <a:fillRef idx="3">
-            <a:schemeClr val="accent1"/>
-          </a:fillRef>
-          <a:effectRef idx="2">
-            <a:schemeClr val="accent1"/>
-          </a:effectRef>
-          <a:fontRef idx="minor">
-            <a:schemeClr val="lt1"/>
-          </a:fontRef>
-        </p:style>
-        <p:txBody>
-          <a:bodyPr rtlCol="0" anchor="ctr"/>
-          <a:lstStyle/>
-          <a:p>
-            <a:endParaRPr/>
-          </a:p>
-        </p:txBody>
-      </p:sp>
-      <p:sp>
-        <p:nvSpPr>
           <p:cNvPr id="37" name="TextBox 36"/>
           <p:cNvSpPr txBox="1"/>
           <p:nvPr/>
         </p:nvSpPr>
         <p:spPr>
           <a:xfrm>
-            <a:off x="6379311" y="4078224"/>
+            <a:off x="6379311" y="4422355"/>
             <a:ext cx="2211247" cy="219456"/>
           </a:xfrm>
           <a:prstGeom prst="rect">
@@ -42073,7 +41964,7 @@
         </p:nvSpPr>
         <p:spPr>
           <a:xfrm>
-            <a:off x="6379311" y="4334256"/>
+            <a:off x="6379311" y="4678387"/>
             <a:ext cx="2211247" cy="438912"/>
           </a:xfrm>
           <a:prstGeom prst="rect">
@@ -42134,7 +42025,7 @@
         </p:nvSpPr>
         <p:spPr>
           <a:xfrm>
-            <a:off x="6379311" y="4828031"/>
+            <a:off x="6379311" y="5172162"/>
             <a:ext cx="2211247" cy="13716"/>
           </a:xfrm>
           <a:prstGeom prst="rect">
@@ -42172,48 +42063,14 @@
       </p:sp>
       <p:sp>
         <p:nvSpPr>
-          <p:cNvPr id="40" name="TextBox 39"/>
-          <p:cNvSpPr txBox="1"/>
-          <p:nvPr/>
-        </p:nvSpPr>
-        <p:spPr>
-          <a:xfrm>
-            <a:off x="6379311" y="4919472"/>
-            <a:ext cx="2211247" cy="1097280"/>
-          </a:xfrm>
-          <a:prstGeom prst="rect">
-            <a:avLst/>
-          </a:prstGeom>
-          <a:noFill/>
-        </p:spPr>
-        <p:txBody>
-          <a:bodyPr wrap="square">
-            <a:spAutoFit/>
-          </a:bodyPr>
-          <a:lstStyle/>
-          <a:p>
-            <a:r>
-              <a:rPr sz="1200" b="0" i="0">
-                <a:solidFill>
-                  <a:srgbClr val="6B7280"/>
-                </a:solidFill>
-                <a:latin typeface="Segoe UI"/>
-              </a:rPr>
-              <a:t>Do we actually need 11M parameters, or does a compact 4-block CNN suffice?</a:t>
-            </a:r>
-          </a:p>
-        </p:txBody>
-      </p:sp>
-      <p:sp>
-        <p:nvSpPr>
           <p:cNvPr id="41" name="Rounded Rectangle 40"/>
           <p:cNvSpPr/>
           <p:nvPr/>
         </p:nvSpPr>
         <p:spPr>
           <a:xfrm>
-            <a:off x="8974607" y="3931920"/>
-            <a:ext cx="2577007" cy="2176272"/>
+            <a:off x="8974607" y="4276051"/>
+            <a:ext cx="2577007" cy="1220725"/>
           </a:xfrm>
           <a:prstGeom prst="roundRect">
             <a:avLst>
@@ -42254,57 +42111,13 @@
       </p:sp>
       <p:sp>
         <p:nvSpPr>
-          <p:cNvPr id="42" name="Rectangle 41"/>
-          <p:cNvSpPr/>
-          <p:nvPr/>
-        </p:nvSpPr>
-        <p:spPr>
-          <a:xfrm>
-            <a:off x="8974607" y="3931920"/>
-            <a:ext cx="2577007" cy="45720"/>
-          </a:xfrm>
-          <a:prstGeom prst="rect">
-            <a:avLst/>
-          </a:prstGeom>
-          <a:solidFill>
-            <a:srgbClr val="2F8F4E"/>
-          </a:solidFill>
-          <a:ln>
-            <a:noFill/>
-          </a:ln>
-          <a:effectLst/>
-        </p:spPr>
-        <p:style>
-          <a:lnRef idx="1">
-            <a:schemeClr val="accent1"/>
-          </a:lnRef>
-          <a:fillRef idx="3">
-            <a:schemeClr val="accent1"/>
-          </a:fillRef>
-          <a:effectRef idx="2">
-            <a:schemeClr val="accent1"/>
-          </a:effectRef>
-          <a:fontRef idx="minor">
-            <a:schemeClr val="lt1"/>
-          </a:fontRef>
-        </p:style>
-        <p:txBody>
-          <a:bodyPr rtlCol="0" anchor="ctr"/>
-          <a:lstStyle/>
-          <a:p>
-            <a:endParaRPr/>
-          </a:p>
-        </p:txBody>
-      </p:sp>
-      <p:sp>
-        <p:nvSpPr>
           <p:cNvPr id="43" name="TextBox 42"/>
           <p:cNvSpPr txBox="1"/>
           <p:nvPr/>
         </p:nvSpPr>
         <p:spPr>
           <a:xfrm>
-            <a:off x="9157487" y="4078224"/>
+            <a:off x="9157487" y="4422355"/>
             <a:ext cx="2211247" cy="219456"/>
           </a:xfrm>
           <a:prstGeom prst="rect">
@@ -42339,7 +42152,7 @@
         </p:nvSpPr>
         <p:spPr>
           <a:xfrm>
-            <a:off x="9157487" y="4334256"/>
+            <a:off x="9157487" y="4678387"/>
             <a:ext cx="2211247" cy="438912"/>
           </a:xfrm>
           <a:prstGeom prst="rect">
@@ -42400,7 +42213,7 @@
         </p:nvSpPr>
         <p:spPr>
           <a:xfrm>
-            <a:off x="9157487" y="4828031"/>
+            <a:off x="9157487" y="5172162"/>
             <a:ext cx="2211247" cy="13716"/>
           </a:xfrm>
           <a:prstGeom prst="rect">
@@ -42433,40 +42246,6 @@
           <a:lstStyle/>
           <a:p>
             <a:endParaRPr/>
-          </a:p>
-        </p:txBody>
-      </p:sp>
-      <p:sp>
-        <p:nvSpPr>
-          <p:cNvPr id="46" name="TextBox 45"/>
-          <p:cNvSpPr txBox="1"/>
-          <p:nvPr/>
-        </p:nvSpPr>
-        <p:spPr>
-          <a:xfrm>
-            <a:off x="9157487" y="4919472"/>
-            <a:ext cx="2211247" cy="1097280"/>
-          </a:xfrm>
-          <a:prstGeom prst="rect">
-            <a:avLst/>
-          </a:prstGeom>
-          <a:noFill/>
-        </p:spPr>
-        <p:txBody>
-          <a:bodyPr wrap="square">
-            <a:spAutoFit/>
-          </a:bodyPr>
-          <a:lstStyle/>
-          <a:p>
-            <a:r>
-              <a:rPr sz="1200" b="0" i="0">
-                <a:solidFill>
-                  <a:srgbClr val="6B7280"/>
-                </a:solidFill>
-                <a:latin typeface="Segoe UI"/>
-              </a:rPr>
-              <a:t>Does global patch self-attention capture script ligatures better than local convs?</a:t>
-            </a:r>
           </a:p>
         </p:txBody>
       </p:sp>
@@ -44296,7 +44075,7 @@
                     <a:lstStyle/>
                     <a:p>
                       <a:r>
-                        <a:rPr sz="1400" b="1" i="0">
+                        <a:rPr sz="1400" b="1" i="0" dirty="0">
                           <a:solidFill>
                             <a:srgbClr val="14213D"/>
                           </a:solidFill>
@@ -44372,50 +44151,6 @@
       </p:sp>
       <p:sp>
         <p:nvSpPr>
-          <p:cNvPr id="24" name="Rectangle 23"/>
-          <p:cNvSpPr/>
-          <p:nvPr/>
-        </p:nvSpPr>
-        <p:spPr>
-          <a:xfrm>
-            <a:off x="640080" y="3931920"/>
-            <a:ext cx="2577007" cy="45720"/>
-          </a:xfrm>
-          <a:prstGeom prst="rect">
-            <a:avLst/>
-          </a:prstGeom>
-          <a:solidFill>
-            <a:srgbClr val="0F7C74"/>
-          </a:solidFill>
-          <a:ln>
-            <a:noFill/>
-          </a:ln>
-          <a:effectLst/>
-        </p:spPr>
-        <p:style>
-          <a:lnRef idx="1">
-            <a:schemeClr val="accent1"/>
-          </a:lnRef>
-          <a:fillRef idx="3">
-            <a:schemeClr val="accent1"/>
-          </a:fillRef>
-          <a:effectRef idx="2">
-            <a:schemeClr val="accent1"/>
-          </a:effectRef>
-          <a:fontRef idx="minor">
-            <a:schemeClr val="lt1"/>
-          </a:fontRef>
-        </p:style>
-        <p:txBody>
-          <a:bodyPr rtlCol="0" anchor="ctr"/>
-          <a:lstStyle/>
-          <a:p>
-            <a:endParaRPr/>
-          </a:p>
-        </p:txBody>
-      </p:sp>
-      <p:sp>
-        <p:nvSpPr>
           <p:cNvPr id="25" name="TextBox 24"/>
           <p:cNvSpPr txBox="1"/>
           <p:nvPr/>
@@ -44554,7 +44289,7 @@
         <p:spPr>
           <a:xfrm>
             <a:off x="822959" y="4919472"/>
-            <a:ext cx="2211247" cy="1097280"/>
+            <a:ext cx="2211247" cy="646331"/>
           </a:xfrm>
           <a:prstGeom prst="rect">
             <a:avLst/>
@@ -44568,14 +44303,20 @@
           <a:lstStyle/>
           <a:p>
             <a:r>
-              <a:rPr sz="1200" b="0" i="0">
+              <a:rPr lang="en-US" sz="1200" dirty="0">
                 <a:solidFill>
                   <a:srgbClr val="6B7280"/>
                 </a:solidFill>
                 <a:latin typeface="Segoe UI"/>
               </a:rPr>
-              <a:t>McNemar paired test shows no statistical difference. Pre-training speeds up learning, but 2 515 crops suffice from scratch.</a:t>
-            </a:r>
+              <a:t>Pre-trained weights didn't make the model smarter they just made it learn faster.</a:t>
+            </a:r>
+            <a:endParaRPr sz="1200" dirty="0">
+              <a:solidFill>
+                <a:srgbClr val="6B7280"/>
+              </a:solidFill>
+              <a:latin typeface="Segoe UI"/>
+            </a:endParaRPr>
           </a:p>
         </p:txBody>
       </p:sp>
@@ -44629,50 +44370,6 @@
       </p:sp>
       <p:sp>
         <p:nvSpPr>
-          <p:cNvPr id="30" name="Rectangle 29"/>
-          <p:cNvSpPr/>
-          <p:nvPr/>
-        </p:nvSpPr>
-        <p:spPr>
-          <a:xfrm>
-            <a:off x="3418255" y="3931920"/>
-            <a:ext cx="2577007" cy="45720"/>
-          </a:xfrm>
-          <a:prstGeom prst="rect">
-            <a:avLst/>
-          </a:prstGeom>
-          <a:solidFill>
-            <a:srgbClr val="C0392B"/>
-          </a:solidFill>
-          <a:ln>
-            <a:noFill/>
-          </a:ln>
-          <a:effectLst/>
-        </p:spPr>
-        <p:style>
-          <a:lnRef idx="1">
-            <a:schemeClr val="accent1"/>
-          </a:lnRef>
-          <a:fillRef idx="3">
-            <a:schemeClr val="accent1"/>
-          </a:fillRef>
-          <a:effectRef idx="2">
-            <a:schemeClr val="accent1"/>
-          </a:effectRef>
-          <a:fontRef idx="minor">
-            <a:schemeClr val="lt1"/>
-          </a:fontRef>
-        </p:style>
-        <p:txBody>
-          <a:bodyPr rtlCol="0" anchor="ctr"/>
-          <a:lstStyle/>
-          <a:p>
-            <a:endParaRPr/>
-          </a:p>
-        </p:txBody>
-      </p:sp>
-      <p:sp>
-        <p:nvSpPr>
           <p:cNvPr id="31" name="TextBox 30"/>
           <p:cNvSpPr txBox="1"/>
           <p:nvPr/>
@@ -44793,7 +44490,7 @@
         <p:spPr>
           <a:xfrm>
             <a:off x="3601135" y="4919472"/>
-            <a:ext cx="2211247" cy="1097280"/>
+            <a:ext cx="2211247" cy="1015663"/>
           </a:xfrm>
           <a:prstGeom prst="rect">
             <a:avLst/>
@@ -44807,14 +44504,20 @@
           <a:lstStyle/>
           <a:p>
             <a:r>
-              <a:rPr sz="1200" b="0" i="0">
+              <a:rPr lang="en-US" sz="1200" dirty="0">
                 <a:solidFill>
                   <a:srgbClr val="6B7280"/>
                 </a:solidFill>
                 <a:latin typeface="Segoe UI"/>
               </a:rPr>
-              <a:t>Off-the-shelf ImageNet filters encode natural textures, not Khmer strokes. The network must be retrained end-to-end.</a:t>
-            </a:r>
+              <a:t>ImageNet knows dogs and cars, not Khmer letters. We must retrain the whole network so it can learn Khmer strokes.</a:t>
+            </a:r>
+            <a:endParaRPr sz="1200" dirty="0">
+              <a:solidFill>
+                <a:srgbClr val="6B7280"/>
+              </a:solidFill>
+              <a:latin typeface="Segoe UI"/>
+            </a:endParaRPr>
           </a:p>
         </p:txBody>
       </p:sp>
@@ -44868,50 +44571,6 @@
       </p:sp>
       <p:sp>
         <p:nvSpPr>
-          <p:cNvPr id="36" name="Rectangle 35"/>
-          <p:cNvSpPr/>
-          <p:nvPr/>
-        </p:nvSpPr>
-        <p:spPr>
-          <a:xfrm>
-            <a:off x="6196431" y="3931920"/>
-            <a:ext cx="2577007" cy="45720"/>
-          </a:xfrm>
-          <a:prstGeom prst="rect">
-            <a:avLst/>
-          </a:prstGeom>
-          <a:solidFill>
-            <a:srgbClr val="C0392B"/>
-          </a:solidFill>
-          <a:ln>
-            <a:noFill/>
-          </a:ln>
-          <a:effectLst/>
-        </p:spPr>
-        <p:style>
-          <a:lnRef idx="1">
-            <a:schemeClr val="accent1"/>
-          </a:lnRef>
-          <a:fillRef idx="3">
-            <a:schemeClr val="accent1"/>
-          </a:fillRef>
-          <a:effectRef idx="2">
-            <a:schemeClr val="accent1"/>
-          </a:effectRef>
-          <a:fontRef idx="minor">
-            <a:schemeClr val="lt1"/>
-          </a:fontRef>
-        </p:style>
-        <p:txBody>
-          <a:bodyPr rtlCol="0" anchor="ctr"/>
-          <a:lstStyle/>
-          <a:p>
-            <a:endParaRPr/>
-          </a:p>
-        </p:txBody>
-      </p:sp>
-      <p:sp>
-        <p:nvSpPr>
           <p:cNvPr id="37" name="TextBox 36"/>
           <p:cNvSpPr txBox="1"/>
           <p:nvPr/>
@@ -45032,7 +44691,7 @@
         <p:spPr>
           <a:xfrm>
             <a:off x="6379311" y="4919472"/>
-            <a:ext cx="2211247" cy="1097280"/>
+            <a:ext cx="2211247" cy="1015663"/>
           </a:xfrm>
           <a:prstGeom prst="rect">
             <a:avLst/>
@@ -45046,14 +44705,20 @@
           <a:lstStyle/>
           <a:p>
             <a:r>
-              <a:rPr sz="1200" b="0" i="0">
+              <a:rPr lang="en-US" sz="1200" dirty="0">
                 <a:solidFill>
                   <a:srgbClr val="6B7280"/>
                 </a:solidFill>
                 <a:latin typeface="Segoe UI"/>
               </a:rPr>
-              <a:t>A 400k-parameter CNN severely under-fits. Separating 26 intricate glyphs requires deep residual or attention capacity.</a:t>
-            </a:r>
+              <a:t>A small 400k model is too simple. Khmer words are complex, so we need a deeper model with more capacity.</a:t>
+            </a:r>
+            <a:endParaRPr sz="1200" dirty="0">
+              <a:solidFill>
+                <a:srgbClr val="6B7280"/>
+              </a:solidFill>
+              <a:latin typeface="Segoe UI"/>
+            </a:endParaRPr>
           </a:p>
         </p:txBody>
       </p:sp>
@@ -45107,50 +44772,6 @@
       </p:sp>
       <p:sp>
         <p:nvSpPr>
-          <p:cNvPr id="42" name="Rectangle 41"/>
-          <p:cNvSpPr/>
-          <p:nvPr/>
-        </p:nvSpPr>
-        <p:spPr>
-          <a:xfrm>
-            <a:off x="8974607" y="3931920"/>
-            <a:ext cx="2577007" cy="45720"/>
-          </a:xfrm>
-          <a:prstGeom prst="rect">
-            <a:avLst/>
-          </a:prstGeom>
-          <a:solidFill>
-            <a:srgbClr val="2F8F4E"/>
-          </a:solidFill>
-          <a:ln>
-            <a:noFill/>
-          </a:ln>
-          <a:effectLst/>
-        </p:spPr>
-        <p:style>
-          <a:lnRef idx="1">
-            <a:schemeClr val="accent1"/>
-          </a:lnRef>
-          <a:fillRef idx="3">
-            <a:schemeClr val="accent1"/>
-          </a:fillRef>
-          <a:effectRef idx="2">
-            <a:schemeClr val="accent1"/>
-          </a:effectRef>
-          <a:fontRef idx="minor">
-            <a:schemeClr val="lt1"/>
-          </a:fontRef>
-        </p:style>
-        <p:txBody>
-          <a:bodyPr rtlCol="0" anchor="ctr"/>
-          <a:lstStyle/>
-          <a:p>
-            <a:endParaRPr/>
-          </a:p>
-        </p:txBody>
-      </p:sp>
-      <p:sp>
-        <p:nvSpPr>
           <p:cNvPr id="43" name="TextBox 42"/>
           <p:cNvSpPr txBox="1"/>
           <p:nvPr/>
@@ -45271,7 +44892,7 @@
         <p:spPr>
           <a:xfrm>
             <a:off x="9157487" y="4919472"/>
-            <a:ext cx="2211247" cy="1097280"/>
+            <a:ext cx="2211247" cy="1015663"/>
           </a:xfrm>
           <a:prstGeom prst="rect">
             <a:avLst/>
@@ -45285,32 +44906,29 @@
           <a:lstStyle/>
           <a:p>
             <a:r>
-              <a:rPr sz="1200" b="0" i="0">
+              <a:rPr lang="en-US" sz="1200" dirty="0">
                 <a:solidFill>
                   <a:srgbClr val="6B7280"/>
                 </a:solidFill>
                 <a:latin typeface="Segoe UI"/>
               </a:rPr>
-              <a:t>Self-attention captures full character ligatures and improves inverted plate reading from 19.4 % to </a:t>
-            </a:r>
-            <a:r>
-              <a:rPr sz="1200" b="1" i="0">
-                <a:solidFill>
-                  <a:srgbClr val="0F7C74"/>
+              <a:t>The Vision Transformer is our best model because its attention mechanism looks at the entire Khmer word at once</a:t>
+            </a:r>
+            <a:r>
+              <a:rPr lang="en-US" sz="1200" i="1" dirty="0">
+                <a:solidFill>
+                  <a:srgbClr val="6B7280"/>
                 </a:solidFill>
                 <a:latin typeface="Segoe UI"/>
               </a:rPr>
-              <a:t>26.8 %</a:t>
-            </a:r>
-            <a:r>
-              <a:rPr sz="1200" b="0" i="0">
-                <a:solidFill>
-                  <a:srgbClr val="6B7280"/>
-                </a:solidFill>
-                <a:latin typeface="Segoe UI"/>
-              </a:rPr>
               <a:t>.</a:t>
             </a:r>
+            <a:endParaRPr sz="1200" b="0" i="0" dirty="0">
+              <a:solidFill>
+                <a:srgbClr val="6B7280"/>
+              </a:solidFill>
+              <a:latin typeface="Segoe UI"/>
+            </a:endParaRPr>
           </a:p>
         </p:txBody>
       </p:sp>

</xml_diff>